<commit_message>
conclusion: do we need MC with Fermi motion -- reconstructed E_gamma smeared 196 MeV rms, t 0.24 GeV2; new figure, report section 7.1, deck slide 10
Co-Authored-By: Claude Fable 5.1 <noreply@anthropic.com>
</commit_message>
<xml_diff>
--- a/docs/jpsi_fermi/talk/Jpsi_Fermi_photoproduction.pptx
+++ b/docs/jpsi_fermi/talk/Jpsi_Fermi_photoproduction.pptx
@@ -3497,7 +3497,7 @@
     <p:bg>
       <p:bgPr>
         <a:solidFill>
-          <a:srgbClr val="1F2A44"/>
+          <a:srgbClr val="FFFFFF"/>
         </a:solidFill>
         <a:effectLst/>
       </p:bgPr>
@@ -3517,8 +3517,120 @@
         </p:nvSpPr>
         <p:spPr>
           <a:xfrm>
-            <a:off x="640080" y="457200"/>
-            <a:ext cx="10972800" cy="731520"/>
+            <a:off x="457200" y="320040"/>
+            <a:ext cx="11247120" cy="685800"/>
+          </a:xfrm>
+          <a:prstGeom prst="rect">
+            <a:avLst/>
+          </a:prstGeom>
+          <a:noFill/>
+        </p:spPr>
+        <p:txBody>
+          <a:bodyPr wrap="square" anchor="ctr" lIns="45720" rIns="45720" tIns="27432" bIns="27432">
+            <a:spAutoFit/>
+          </a:bodyPr>
+          <a:lstStyle/>
+          <a:p>
+            <a:pPr algn="l">
+              <a:lnSpc>
+                <a:spcPct val="105000"/>
+              </a:lnSpc>
+              <a:spcAft>
+                <a:spcPts val="400"/>
+              </a:spcAft>
+            </a:pPr>
+            <a:r>
+              <a:rPr sz="2600" b="1" i="0">
+                <a:solidFill>
+                  <a:srgbClr val="1A1A1A"/>
+                </a:solidFill>
+                <a:latin typeface="Cambria"/>
+              </a:rPr>
+              <a:t>Conclusion: do we need a Monte Carlo with Fermi motion?</a:t>
+            </a:r>
+          </a:p>
+        </p:txBody>
+      </p:sp>
+      <p:pic>
+        <p:nvPicPr>
+          <p:cNvPr id="3" name="Picture 2" descr="fig_ereco.png"/>
+          <p:cNvPicPr>
+            <a:picLocks noChangeAspect="1"/>
+          </p:cNvPicPr>
+          <p:nvPr/>
+        </p:nvPicPr>
+        <p:blipFill>
+          <a:blip r:embed="rId2"/>
+          <a:stretch>
+            <a:fillRect/>
+          </a:stretch>
+        </p:blipFill>
+        <p:spPr>
+          <a:xfrm>
+            <a:off x="365760" y="1051560"/>
+            <a:ext cx="7223760" cy="3054982"/>
+          </a:xfrm>
+          <a:prstGeom prst="rect">
+            <a:avLst/>
+          </a:prstGeom>
+        </p:spPr>
+      </p:pic>
+      <p:sp>
+        <p:nvSpPr>
+          <p:cNvPr id="4" name="Rounded Rectangle 3"/>
+          <p:cNvSpPr/>
+          <p:nvPr/>
+        </p:nvSpPr>
+        <p:spPr>
+          <a:xfrm>
+            <a:off x="7863840" y="1051560"/>
+            <a:ext cx="3886200" cy="1417320"/>
+          </a:xfrm>
+          <a:prstGeom prst="roundRect">
+            <a:avLst>
+              <a:gd name="adj" fmla="val 6000"/>
+            </a:avLst>
+          </a:prstGeom>
+          <a:solidFill>
+            <a:srgbClr val="EEF2F7"/>
+          </a:solidFill>
+          <a:ln>
+            <a:noFill/>
+          </a:ln>
+          <a:effectLst/>
+        </p:spPr>
+        <p:style>
+          <a:lnRef idx="1">
+            <a:schemeClr val="accent1"/>
+          </a:lnRef>
+          <a:fillRef idx="3">
+            <a:schemeClr val="accent1"/>
+          </a:fillRef>
+          <a:effectRef idx="2">
+            <a:schemeClr val="accent1"/>
+          </a:effectRef>
+          <a:fontRef idx="minor">
+            <a:schemeClr val="lt1"/>
+          </a:fontRef>
+        </p:style>
+        <p:txBody>
+          <a:bodyPr rtlCol="0" anchor="ctr"/>
+          <a:lstStyle/>
+          <a:p>
+            <a:pPr algn="ctr"/>
+          </a:p>
+        </p:txBody>
+      </p:sp>
+      <p:sp>
+        <p:nvSpPr>
+          <p:cNvPr id="5" name="TextBox 4"/>
+          <p:cNvSpPr txBox="1"/>
+          <p:nvPr/>
+        </p:nvSpPr>
+        <p:spPr>
+          <a:xfrm>
+            <a:off x="8001000" y="1143000"/>
+            <a:ext cx="3611880" cy="1234440"/>
           </a:xfrm>
           <a:prstGeom prst="rect">
             <a:avLst/>
@@ -3536,31 +3648,105 @@
                 <a:spcPct val="105000"/>
               </a:lnSpc>
               <a:spcAft>
-                <a:spcPts val="400"/>
-              </a:spcAft>
-            </a:pPr>
-            <a:r>
-              <a:rPr sz="3400" b="1" i="0">
-                <a:solidFill>
-                  <a:srgbClr val="FFFFFF"/>
-                </a:solidFill>
-                <a:latin typeface="Cambria"/>
-              </a:rPr>
-              <a:t>Summary and next steps</a:t>
-            </a:r>
-          </a:p>
-        </p:txBody>
-      </p:sp>
-      <p:sp>
-        <p:nvSpPr>
-          <p:cNvPr id="3" name="TextBox 2"/>
+                <a:spcPts val="300"/>
+              </a:spcAft>
+            </a:pPr>
+            <a:r>
+              <a:rPr sz="1300" b="1" i="0">
+                <a:solidFill>
+                  <a:srgbClr val="009E73"/>
+                </a:solidFill>
+                <a:latin typeface="Calibri"/>
+              </a:rPr>
+              <a:t>No, for the yield at the true E_γ</a:t>
+            </a:r>
+          </a:p>
+          <a:p>
+            <a:pPr algn="l">
+              <a:lnSpc>
+                <a:spcPct val="105000"/>
+              </a:lnSpc>
+              <a:spcAft>
+                <a:spcPts val="300"/>
+              </a:spcAft>
+            </a:pPr>
+            <a:r>
+              <a:rPr sz="1100" b="0" i="0">
+                <a:solidFill>
+                  <a:srgbClr val="1A1A1A"/>
+                </a:solidFill>
+                <a:latin typeface="Calibri"/>
+              </a:rPr>
+              <a:t>•  </a:t>
+            </a:r>
+            <a:r>
+              <a:rPr sz="1100" b="0" i="0">
+                <a:solidFill>
+                  <a:srgbClr val="1A1A1A"/>
+                </a:solidFill>
+                <a:latin typeface="Calibri"/>
+              </a:rPr>
+              <a:t>above 8.6 GeV a free-neutron generator gives the yield per neutron to better than 1 % in every bin, and the same t distribution at the true s</a:t>
+            </a:r>
+          </a:p>
+        </p:txBody>
+      </p:sp>
+      <p:sp>
+        <p:nvSpPr>
+          <p:cNvPr id="6" name="Rounded Rectangle 5"/>
+          <p:cNvSpPr/>
+          <p:nvPr/>
+        </p:nvSpPr>
+        <p:spPr>
+          <a:xfrm>
+            <a:off x="7863840" y="2606040"/>
+            <a:ext cx="3886200" cy="2743200"/>
+          </a:xfrm>
+          <a:prstGeom prst="roundRect">
+            <a:avLst>
+              <a:gd name="adj" fmla="val 6000"/>
+            </a:avLst>
+          </a:prstGeom>
+          <a:solidFill>
+            <a:srgbClr val="EEF2F7"/>
+          </a:solidFill>
+          <a:ln>
+            <a:noFill/>
+          </a:ln>
+          <a:effectLst/>
+        </p:spPr>
+        <p:style>
+          <a:lnRef idx="1">
+            <a:schemeClr val="accent1"/>
+          </a:lnRef>
+          <a:fillRef idx="3">
+            <a:schemeClr val="accent1"/>
+          </a:fillRef>
+          <a:effectRef idx="2">
+            <a:schemeClr val="accent1"/>
+          </a:effectRef>
+          <a:fontRef idx="minor">
+            <a:schemeClr val="lt1"/>
+          </a:fontRef>
+        </p:style>
+        <p:txBody>
+          <a:bodyPr rtlCol="0" anchor="ctr"/>
+          <a:lstStyle/>
+          <a:p>
+            <a:pPr algn="ctr"/>
+          </a:p>
+        </p:txBody>
+      </p:sp>
+      <p:sp>
+        <p:nvSpPr>
+          <p:cNvPr id="7" name="TextBox 6"/>
           <p:cNvSpPr txBox="1"/>
           <p:nvPr/>
         </p:nvSpPr>
         <p:spPr>
           <a:xfrm>
-            <a:off x="640080" y="1371600"/>
-            <a:ext cx="10972800" cy="4206240"/>
+            <a:off x="8001000" y="2697480"/>
+            <a:ext cx="3611880" cy="2560320"/>
           </a:xfrm>
           <a:prstGeom prst="rect">
             <a:avLst/>
@@ -3578,234 +3764,115 @@
                 <a:spcPct val="105000"/>
               </a:lnSpc>
               <a:spcAft>
-                <a:spcPts val="900"/>
-              </a:spcAft>
-            </a:pPr>
-            <a:r>
-              <a:rPr sz="1400" b="0" i="0">
-                <a:solidFill>
-                  <a:srgbClr val="FFFFFF"/>
+                <a:spcPts val="300"/>
+              </a:spcAft>
+            </a:pPr>
+            <a:r>
+              <a:rPr sz="1300" b="1" i="0">
+                <a:solidFill>
+                  <a:srgbClr val="D55500"/>
+                </a:solidFill>
+                <a:latin typeface="Calibri"/>
+              </a:rPr>
+              <a:t>Yes, for everything an analysis measures</a:t>
+            </a:r>
+          </a:p>
+          <a:p>
+            <a:pPr algn="l">
+              <a:lnSpc>
+                <a:spcPct val="105000"/>
+              </a:lnSpc>
+              <a:spcAft>
+                <a:spcPts val="300"/>
+              </a:spcAft>
+            </a:pPr>
+            <a:r>
+              <a:rPr sz="1100" b="0" i="0">
+                <a:solidFill>
+                  <a:srgbClr val="1A1A1A"/>
                 </a:solidFill>
                 <a:latin typeface="Calibri"/>
               </a:rPr>
               <a:t>•  </a:t>
             </a:r>
             <a:r>
-              <a:rPr sz="1400" b="1" i="0">
-                <a:solidFill>
-                  <a:srgbClr val="C9D8EE"/>
-                </a:solidFill>
-                <a:latin typeface="Calibri"/>
-              </a:rPr>
-              <a:t>New photoproduction mode of exclurad_py:</a:t>
-            </a:r>
-            <a:r>
-              <a:rPr sz="1400" b="0" i="0">
-                <a:solidFill>
-                  <a:srgbClr val="FFFFFF"/>
-                </a:solidFill>
-                <a:latin typeface="Calibri"/>
-              </a:rPr>
-              <a:t> bremsstrahlung beam with the correct endpoint, AV18 spectator deuteron, exact kinematics, strict majorant; 0.65 ms per event on the deuteron.</a:t>
-            </a:r>
-          </a:p>
-          <a:p>
-            <a:pPr algn="l">
-              <a:lnSpc>
-                <a:spcPct val="105000"/>
-              </a:lnSpc>
-              <a:spcAft>
-                <a:spcPts val="900"/>
-              </a:spcAft>
-            </a:pPr>
-            <a:r>
-              <a:rPr sz="1400" b="0" i="0">
-                <a:solidFill>
-                  <a:srgbClr val="FFFFFF"/>
+              <a:rPr sz="1100" b="0" i="0">
+                <a:solidFill>
+                  <a:srgbClr val="1A1A1A"/>
+                </a:solidFill>
+                <a:latin typeface="Calibri"/>
+              </a:rPr>
+              <a:t>E_γ from the J/ψ alone (neutron at rest): smeared by 196 MeV rms above 8.6 GeV, shifted +120 MeV in 8.6–9.0 and +250 MeV next to threshold; 23–45 % of events move by more than 150 MeV</a:t>
+            </a:r>
+          </a:p>
+          <a:p>
+            <a:pPr algn="l">
+              <a:lnSpc>
+                <a:spcPct val="105000"/>
+              </a:lnSpc>
+              <a:spcAft>
+                <a:spcPts val="300"/>
+              </a:spcAft>
+            </a:pPr>
+            <a:r>
+              <a:rPr sz="1100" b="0" i="0">
+                <a:solidFill>
+                  <a:srgbClr val="1A1A1A"/>
                 </a:solidFill>
                 <a:latin typeface="Calibri"/>
               </a:rPr>
               <a:t>•  </a:t>
             </a:r>
             <a:r>
-              <a:rPr sz="1400" b="1" i="0">
-                <a:solidFill>
-                  <a:srgbClr val="C9D8EE"/>
-                </a:solidFill>
-                <a:latin typeface="Calibri"/>
-              </a:rPr>
-              <a:t>The flux factor (1 − β_z) of the moving nucleon is essential:</a:t>
-            </a:r>
-            <a:r>
-              <a:rPr sz="1400" b="0" i="0">
-                <a:solidFill>
-                  <a:srgbClr val="FFFFFF"/>
-                </a:solidFill>
-                <a:latin typeface="Calibri"/>
-              </a:rPr>
-              <a:t> +4 %, and it cancels the −4 % binding effect. The same factor is missing in the electroproduction Fermi path (π⁰: 0.2 % on the yield, 1–3 % tilt in W_obs and y, 9 % in the tail below the box edge).</a:t>
-            </a:r>
-          </a:p>
-          <a:p>
-            <a:pPr algn="l">
-              <a:lnSpc>
-                <a:spcPct val="105000"/>
-              </a:lnSpc>
-              <a:spcAft>
-                <a:spcPts val="900"/>
-              </a:spcAft>
-            </a:pPr>
-            <a:r>
-              <a:rPr sz="1400" b="0" i="0">
-                <a:solidFill>
-                  <a:srgbClr val="FFFFFF"/>
+              <a:rPr sz="1100" b="0" i="0">
+                <a:solidFill>
+                  <a:srgbClr val="1A1A1A"/>
+                </a:solidFill>
+                <a:latin typeface="Calibri"/>
+              </a:rPr>
+              <a:t>t from the reconstructed photon: 0.24 GeV² rms, comparable to 1/b</a:t>
+            </a:r>
+          </a:p>
+          <a:p>
+            <a:pPr algn="l">
+              <a:lnSpc>
+                <a:spcPct val="105000"/>
+              </a:lnSpc>
+              <a:spcAft>
+                <a:spcPts val="300"/>
+              </a:spcAft>
+            </a:pPr>
+            <a:r>
+              <a:rPr sz="1100" b="0" i="0">
+                <a:solidFill>
+                  <a:srgbClr val="1A1A1A"/>
                 </a:solidFill>
                 <a:latin typeface="Calibri"/>
               </a:rPr>
               <a:t>•  </a:t>
             </a:r>
             <a:r>
-              <a:rPr sz="1400" b="1" i="0">
-                <a:solidFill>
-                  <a:srgbClr val="C9D8EE"/>
-                </a:solidFill>
-                <a:latin typeface="Calibri"/>
-              </a:rPr>
-              <a:t>Above 8.6 GeV Fermi motion changes the yield per neutron by less than 1 %</a:t>
-            </a:r>
-            <a:r>
-              <a:rPr sz="1400" b="0" i="0">
-                <a:solidFill>
-                  <a:srgbClr val="FFFFFF"/>
-                </a:solidFill>
-                <a:latin typeface="Calibri"/>
-              </a:rPr>
-              <a:t> (mean 0.9944 ± 0.0003, every 100 MeV bin within 0.99–1.00).</a:t>
-            </a:r>
-          </a:p>
-          <a:p>
-            <a:pPr algn="l">
-              <a:lnSpc>
-                <a:spcPct val="105000"/>
-              </a:lnSpc>
-              <a:spcAft>
-                <a:spcPts val="900"/>
-              </a:spcAft>
-            </a:pPr>
-            <a:r>
-              <a:rPr sz="1400" b="0" i="0">
-                <a:solidFill>
-                  <a:srgbClr val="FFFFFF"/>
-                </a:solidFill>
-                <a:latin typeface="Calibri"/>
-              </a:rPr>
-              <a:t>•  </a:t>
-            </a:r>
-            <a:r>
-              <a:rPr sz="1400" b="1" i="0">
-                <a:solidFill>
-                  <a:srgbClr val="C9D8EE"/>
-                </a:solidFill>
-                <a:latin typeface="Calibri"/>
-              </a:rPr>
-              <a:t>Near and below threshold it is everything:</a:t>
-            </a:r>
-            <a:r>
-              <a:rPr sz="1400" b="0" i="0">
-                <a:solidFill>
-                  <a:srgbClr val="FFFFFF"/>
-                </a:solidFill>
-                <a:latin typeface="Calibri"/>
-              </a:rPr>
-              <a:t> 1.09 and 1.78 in the two bins above 8.20 GeV, 2.55 % of the yield below it, spectator protons of 230–400 MeV/c that CLAS12 can see.</a:t>
-            </a:r>
-          </a:p>
-          <a:p>
-            <a:pPr algn="l">
-              <a:lnSpc>
-                <a:spcPct val="105000"/>
-              </a:lnSpc>
-              <a:spcAft>
-                <a:spcPts val="900"/>
-              </a:spcAft>
-            </a:pPr>
-            <a:r>
-              <a:rPr sz="1400" b="0" i="0">
-                <a:solidFill>
-                  <a:srgbClr val="FFFFFF"/>
-                </a:solidFill>
-                <a:latin typeface="Calibri"/>
-              </a:rPr>
-              <a:t>•  </a:t>
-            </a:r>
-            <a:r>
-              <a:rPr sz="1400" b="1" i="0">
-                <a:solidFill>
-                  <a:srgbClr val="C9D8EE"/>
-                </a:solidFill>
-                <a:latin typeface="Calibri"/>
-              </a:rPr>
-              <a:t>roberts2026 vs CLAS12:</a:t>
-            </a:r>
-            <a:r>
-              <a:rPr sz="1400" b="0" i="0">
-                <a:solidFill>
-                  <a:srgbClr val="FFFFFF"/>
-                </a:solidFill>
-                <a:latin typeface="Calibri"/>
-              </a:rPr>
-              <a:t> agrees to 9.6 GeV, 20–30 % low above; the t slope holds to 2 GeV². Refit A, α, B, b to the CLAS12 tables.</a:t>
-            </a:r>
-          </a:p>
-          <a:p>
-            <a:pPr algn="l">
-              <a:lnSpc>
-                <a:spcPct val="105000"/>
-              </a:lnSpc>
-              <a:spcAft>
-                <a:spcPts val="900"/>
-              </a:spcAft>
-            </a:pPr>
-            <a:r>
-              <a:rPr sz="1400" b="0" i="0">
-                <a:solidFill>
-                  <a:srgbClr val="FFFFFF"/>
-                </a:solidFill>
-                <a:latin typeface="Calibri"/>
-              </a:rPr>
-              <a:t>•  </a:t>
-            </a:r>
-            <a:r>
-              <a:rPr sz="1400" b="1" i="0">
-                <a:solidFill>
-                  <a:srgbClr val="C9D8EE"/>
-                </a:solidFill>
-                <a:latin typeface="Calibri"/>
-              </a:rPr>
-              <a:t>Radiative corrections:</a:t>
-            </a:r>
-            <a:r>
-              <a:rPr sz="1400" b="0" i="0">
-                <a:solidFill>
-                  <a:srgbClr val="FFFFFF"/>
-                </a:solidFill>
-                <a:latin typeface="Calibri"/>
-              </a:rPr>
-              <a:t> none for the real-photon process itself; J/ψ → e⁺e⁻γ decay radiation (15–20 % below 3.0 GeV) must be added; for absolute CLAS12 yields the quasi-real electro path with RC is the right generator.</a:t>
-            </a:r>
-          </a:p>
-        </p:txBody>
-      </p:sp>
-      <p:sp>
-        <p:nvSpPr>
-          <p:cNvPr id="4" name="TextBox 3"/>
+              <a:rPr sz="1100" b="0" i="0">
+                <a:solidFill>
+                  <a:srgbClr val="1A1A1A"/>
+                </a:solidFill>
+                <a:latin typeface="Calibri"/>
+              </a:rPr>
+              <a:t>threshold region (ratio 1.09 and 1.78), the 2.55 % below it, spectator protons, exclusivity-cut efficiencies: all Fermi motion</a:t>
+            </a:r>
+          </a:p>
+        </p:txBody>
+      </p:sp>
+      <p:sp>
+        <p:nvSpPr>
+          <p:cNvPr id="8" name="TextBox 7"/>
           <p:cNvSpPr txBox="1"/>
           <p:nvPr/>
         </p:nvSpPr>
         <p:spPr>
           <a:xfrm>
-            <a:off x="640080" y="5806440"/>
-            <a:ext cx="10972800" cy="640080"/>
+            <a:off x="457200" y="4343400"/>
+            <a:ext cx="7132320" cy="960120"/>
           </a:xfrm>
           <a:prstGeom prst="rect">
             <a:avLst/>
@@ -3827,27 +3894,92 @@
               </a:spcAft>
             </a:pPr>
             <a:r>
-              <a:rPr sz="1100" b="0" i="0">
-                <a:solidFill>
-                  <a:srgbClr val="C9D8EE"/>
-                </a:solidFill>
-                <a:latin typeface="Calibri"/>
-              </a:rPr>
-              <a:t>Report: docs/jpsi_fermi/report/jpsi_fermi_photoproduction.pdf (branch jpsi-fermi)  ·  OneDrive Work/2026_Jpsi_Fermi_photoproduction  ·  samples /Volumes/wd_14tb/aao_norad_kin/jpsi_fermi/photo20M</a:t>
-            </a:r>
-          </a:p>
-        </p:txBody>
-      </p:sp>
-      <p:sp>
-        <p:nvSpPr>
-          <p:cNvPr id="5" name="TextBox 4"/>
+              <a:rPr sz="1400" b="1" i="0">
+                <a:solidFill>
+                  <a:srgbClr val="0072B2"/>
+                </a:solidFill>
+                <a:latin typeface="Calibri"/>
+              </a:rPr>
+              <a:t>Bottom line</a:t>
+            </a:r>
+          </a:p>
+          <a:p>
+            <a:pPr algn="l">
+              <a:lnSpc>
+                <a:spcPct val="105000"/>
+              </a:lnSpc>
+              <a:spcAft>
+                <a:spcPts val="400"/>
+              </a:spcAft>
+            </a:pPr>
+            <a:r>
+              <a:rPr sz="1200" b="0" i="0">
+                <a:solidFill>
+                  <a:srgbClr val="1A1A1A"/>
+                </a:solidFill>
+                <a:latin typeface="Calibri"/>
+              </a:rPr>
+              <a:t>Generate deuterium with Fermi motion always: it costs 0.65 ms per event and passes every acceptance test. The free-neutron sample keeps one role, the cross-check that isolates the effect. In the E_γ bins of the CLAS12 analysis (150–450 MeV wide) the migration from Fermi motion is larger than the detector resolution.</a:t>
+            </a:r>
+          </a:p>
+        </p:txBody>
+      </p:sp>
+      <p:sp>
+        <p:nvSpPr>
+          <p:cNvPr id="9" name="Rounded Rectangle 8"/>
+          <p:cNvSpPr/>
+          <p:nvPr/>
+        </p:nvSpPr>
+        <p:spPr>
+          <a:xfrm>
+            <a:off x="457200" y="5394960"/>
+            <a:ext cx="11292840" cy="960120"/>
+          </a:xfrm>
+          <a:prstGeom prst="roundRect">
+            <a:avLst>
+              <a:gd name="adj" fmla="val 6000"/>
+            </a:avLst>
+          </a:prstGeom>
+          <a:solidFill>
+            <a:srgbClr val="EEF2F7"/>
+          </a:solidFill>
+          <a:ln>
+            <a:noFill/>
+          </a:ln>
+          <a:effectLst/>
+        </p:spPr>
+        <p:style>
+          <a:lnRef idx="1">
+            <a:schemeClr val="accent1"/>
+          </a:lnRef>
+          <a:fillRef idx="3">
+            <a:schemeClr val="accent1"/>
+          </a:fillRef>
+          <a:effectRef idx="2">
+            <a:schemeClr val="accent1"/>
+          </a:effectRef>
+          <a:fontRef idx="minor">
+            <a:schemeClr val="lt1"/>
+          </a:fontRef>
+        </p:style>
+        <p:txBody>
+          <a:bodyPr rtlCol="0" anchor="ctr"/>
+          <a:lstStyle/>
+          <a:p>
+            <a:pPr algn="ctr"/>
+          </a:p>
+        </p:txBody>
+      </p:sp>
+      <p:sp>
+        <p:nvSpPr>
+          <p:cNvPr id="10" name="TextBox 9"/>
           <p:cNvSpPr txBox="1"/>
           <p:nvPr/>
         </p:nvSpPr>
         <p:spPr>
           <a:xfrm>
-            <a:off x="457200" y="6473952"/>
-            <a:ext cx="8229600" cy="274320"/>
+            <a:off x="594360" y="5486400"/>
+            <a:ext cx="11018519" cy="777240"/>
           </a:xfrm>
           <a:prstGeom prst="rect">
             <a:avLst/>
@@ -3865,31 +3997,59 @@
                 <a:spcPct val="105000"/>
               </a:lnSpc>
               <a:spcAft>
-                <a:spcPts val="400"/>
-              </a:spcAft>
-            </a:pPr>
-            <a:r>
-              <a:rPr sz="900" b="0" i="0">
-                <a:solidFill>
-                  <a:srgbClr val="C9D8EE"/>
-                </a:solidFill>
-                <a:latin typeface="Calibri"/>
-              </a:rPr>
-              <a:t>V. Kubarovsky · Fermi motion in untagged J/ψ photoproduction · 27 September 2026</a:t>
-            </a:r>
-          </a:p>
-        </p:txBody>
-      </p:sp>
-      <p:sp>
-        <p:nvSpPr>
-          <p:cNvPr id="6" name="TextBox 5"/>
+                <a:spcPts val="300"/>
+              </a:spcAft>
+            </a:pPr>
+            <a:r>
+              <a:rPr sz="1300" b="1" i="0">
+                <a:solidFill>
+                  <a:srgbClr val="0072B2"/>
+                </a:solidFill>
+                <a:latin typeface="Calibri"/>
+              </a:rPr>
+              <a:t>Next steps</a:t>
+            </a:r>
+          </a:p>
+          <a:p>
+            <a:pPr algn="l">
+              <a:lnSpc>
+                <a:spcPct val="105000"/>
+              </a:lnSpc>
+              <a:spcAft>
+                <a:spcPts val="300"/>
+              </a:spcAft>
+            </a:pPr>
+            <a:r>
+              <a:rPr sz="1100" b="0" i="0">
+                <a:solidFill>
+                  <a:srgbClr val="1A1A1A"/>
+                </a:solidFill>
+                <a:latin typeface="Calibri"/>
+              </a:rPr>
+              <a:t>•  </a:t>
+            </a:r>
+            <a:r>
+              <a:rPr sz="1100" b="0" i="0">
+                <a:solidFill>
+                  <a:srgbClr val="1A1A1A"/>
+                </a:solidFill>
+                <a:latin typeface="Calibri"/>
+              </a:rPr>
+              <a:t>J/ψ → e⁺e⁻γ decay radiation in the generator (15–20 % of decays below 3.0 GeV)  ·  flux factor (1 − β_z) in the electroproduction Fermi path  ·  refit A, α, B, b to the CLAS12 tables  ·  quasi-real electroproduction twin with RC for absolute CLAS12 yields</a:t>
+            </a:r>
+          </a:p>
+        </p:txBody>
+      </p:sp>
+      <p:sp>
+        <p:nvSpPr>
+          <p:cNvPr id="11" name="TextBox 10"/>
           <p:cNvSpPr txBox="1"/>
           <p:nvPr/>
         </p:nvSpPr>
         <p:spPr>
           <a:xfrm>
-            <a:off x="11155680" y="6473952"/>
-            <a:ext cx="594360" cy="274320"/>
+            <a:off x="457200" y="6473952"/>
+            <a:ext cx="8229600" cy="274320"/>
           </a:xfrm>
           <a:prstGeom prst="rect">
             <a:avLst/>
@@ -3902,6 +4062,48 @@
           </a:bodyPr>
           <a:lstStyle/>
           <a:p>
+            <a:pPr algn="l">
+              <a:lnSpc>
+                <a:spcPct val="105000"/>
+              </a:lnSpc>
+              <a:spcAft>
+                <a:spcPts val="400"/>
+              </a:spcAft>
+            </a:pPr>
+            <a:r>
+              <a:rPr sz="900" b="0" i="0">
+                <a:solidFill>
+                  <a:srgbClr val="5F636B"/>
+                </a:solidFill>
+                <a:latin typeface="Calibri"/>
+              </a:rPr>
+              <a:t>V. Kubarovsky · Fermi motion in untagged J/ψ photoproduction · 27 September 2026</a:t>
+            </a:r>
+          </a:p>
+        </p:txBody>
+      </p:sp>
+      <p:sp>
+        <p:nvSpPr>
+          <p:cNvPr id="12" name="TextBox 11"/>
+          <p:cNvSpPr txBox="1"/>
+          <p:nvPr/>
+        </p:nvSpPr>
+        <p:spPr>
+          <a:xfrm>
+            <a:off x="11155680" y="6473952"/>
+            <a:ext cx="594360" cy="274320"/>
+          </a:xfrm>
+          <a:prstGeom prst="rect">
+            <a:avLst/>
+          </a:prstGeom>
+          <a:noFill/>
+        </p:spPr>
+        <p:txBody>
+          <a:bodyPr wrap="square" anchor="t" lIns="45720" rIns="45720" tIns="27432" bIns="27432">
+            <a:spAutoFit/>
+          </a:bodyPr>
+          <a:lstStyle/>
+          <a:p>
             <a:pPr algn="r">
               <a:lnSpc>
                 <a:spcPct val="105000"/>
@@ -3913,7 +4115,7 @@
             <a:r>
               <a:rPr sz="900" b="0" i="0">
                 <a:solidFill>
-                  <a:srgbClr val="C9D8EE"/>
+                  <a:srgbClr val="5F636B"/>
                 </a:solidFill>
                 <a:latin typeface="Calibri"/>
               </a:rPr>

</xml_diff>

<commit_message>
report section 7 and deck slides 10-11: photon energy from the final state (Eq. 10), W as the cross-section variable, effective flux in W, off-shellness, recipe
Co-Authored-By: Claude Fable 5.1 <noreply@anthropic.com>
</commit_message>
<xml_diff>
--- a/docs/jpsi_fermi/talk/Jpsi_Fermi_photoproduction.pptx
+++ b/docs/jpsi_fermi/talk/Jpsi_Fermi_photoproduction.pptx
@@ -15,6 +15,8 @@
     <p:sldId id="263" r:id="rId14"/>
     <p:sldId id="264" r:id="rId15"/>
     <p:sldId id="265" r:id="rId16"/>
+    <p:sldId id="266" r:id="rId17"/>
+    <p:sldId id="267" r:id="rId18"/>
   </p:sldIdLst>
   <p:sldSz cx="12191695" cy="6858000" type="screen4x3"/>
   <p:notesSz cx="6858000" cy="9144000"/>
@@ -3546,14 +3548,14 @@
                 </a:solidFill>
                 <a:latin typeface="Cambria"/>
               </a:rPr>
-              <a:t>Conclusion: do we need a Monte Carlo with Fermi motion?</a:t>
+              <a:t>Photon energy from the final state: Eq. 10 of Liu et al., PRC 109, 065206</a:t>
             </a:r>
           </a:p>
         </p:txBody>
       </p:sp>
       <p:pic>
         <p:nvPicPr>
-          <p:cNvPr id="3" name="Picture 2" descr="fig_ereco.png"/>
+          <p:cNvPr id="3" name="Picture 2" descr="jpsi_egamma_estimators.png"/>
           <p:cNvPicPr>
             <a:picLocks noChangeAspect="1"/>
           </p:cNvPicPr>
@@ -3567,8 +3569,8 @@
         </p:blipFill>
         <p:spPr>
           <a:xfrm>
-            <a:off x="365760" y="1051560"/>
-            <a:ext cx="7223760" cy="3054982"/>
+            <a:off x="365760" y="1005840"/>
+            <a:ext cx="6668508" cy="5120640"/>
           </a:xfrm>
           <a:prstGeom prst="rect">
             <a:avLst/>
@@ -3583,8 +3585,8 @@
         </p:nvSpPr>
         <p:spPr>
           <a:xfrm>
-            <a:off x="7863840" y="1051560"/>
-            <a:ext cx="3886200" cy="1417320"/>
+            <a:off x="8001000" y="1005840"/>
+            <a:ext cx="3749039" cy="2148840"/>
           </a:xfrm>
           <a:prstGeom prst="roundRect">
             <a:avLst>
@@ -3629,8 +3631,8 @@
         </p:nvSpPr>
         <p:spPr>
           <a:xfrm>
-            <a:off x="8001000" y="1143000"/>
-            <a:ext cx="3611880" cy="1234440"/>
+            <a:off x="8138160" y="1097280"/>
+            <a:ext cx="3474720" cy="1965960"/>
           </a:xfrm>
           <a:prstGeom prst="rect">
             <a:avLst/>
@@ -3652,13 +3654,13 @@
               </a:spcAft>
             </a:pPr>
             <a:r>
-              <a:rPr sz="1300" b="1" i="0">
-                <a:solidFill>
-                  <a:srgbClr val="009E73"/>
-                </a:solidFill>
-                <a:latin typeface="Calibri"/>
-              </a:rPr>
-              <a:t>No, for the yield at the true E_γ</a:t>
+              <a:rPr sz="1250" b="1" i="0">
+                <a:solidFill>
+                  <a:srgbClr val="0072B2"/>
+                </a:solidFill>
+                <a:latin typeface="Calibri"/>
+              </a:rPr>
+              <a:t>Exact: spectator proton on shell</a:t>
             </a:r>
           </a:p>
           <a:p>
@@ -3671,7 +3673,7 @@
               </a:spcAft>
             </a:pPr>
             <a:r>
-              <a:rPr sz="1100" b="0" i="0">
+              <a:rPr sz="1050" b="0" i="0">
                 <a:solidFill>
                   <a:srgbClr val="1A1A1A"/>
                 </a:solidFill>
@@ -3680,13 +3682,69 @@
               <a:t>•  </a:t>
             </a:r>
             <a:r>
-              <a:rPr sz="1100" b="0" i="0">
-                <a:solidFill>
-                  <a:srgbClr val="1A1A1A"/>
-                </a:solidFill>
-                <a:latin typeface="Calibri"/>
-              </a:rPr>
-              <a:t>above 8.6 GeV a free-neutron generator gives the yield per neutron to better than 1 % in every bin, and the same t distribution at the true s</a:t>
+              <a:rPr sz="1050" b="1" i="0">
+                <a:solidFill>
+                  <a:srgbClr val="1A1A1A"/>
+                </a:solidFill>
+                <a:latin typeface="Calibri"/>
+              </a:rPr>
+              <a:t>E_γ = [(E_ψ+E_n−M_d)² − |p_ψ+p_n|² − M_p²] / 2(E_ψ+E_n−p_zψ−p_zn−M_d)</a:t>
+            </a:r>
+          </a:p>
+          <a:p>
+            <a:pPr algn="l">
+              <a:lnSpc>
+                <a:spcPct val="105000"/>
+              </a:lnSpc>
+              <a:spcAft>
+                <a:spcPts val="300"/>
+              </a:spcAft>
+            </a:pPr>
+            <a:r>
+              <a:rPr sz="1050" b="0" i="0">
+                <a:solidFill>
+                  <a:srgbClr val="1A1A1A"/>
+                </a:solidFill>
+                <a:latin typeface="Calibri"/>
+              </a:rPr>
+              <a:t>•  </a:t>
+            </a:r>
+            <a:r>
+              <a:rPr sz="1050" b="0" i="0">
+                <a:solidFill>
+                  <a:srgbClr val="1A1A1A"/>
+                </a:solidFill>
+                <a:latin typeface="Calibri"/>
+              </a:rPr>
+              <a:t>no Fermi-motion model; gives p_s and m* of the struck neutron event by event</a:t>
+            </a:r>
+          </a:p>
+          <a:p>
+            <a:pPr algn="l">
+              <a:lnSpc>
+                <a:spcPct val="105000"/>
+              </a:lnSpc>
+              <a:spcAft>
+                <a:spcPts val="300"/>
+              </a:spcAft>
+            </a:pPr>
+            <a:r>
+              <a:rPr sz="1050" b="0" i="0">
+                <a:solidFill>
+                  <a:srgbClr val="1A1A1A"/>
+                </a:solidFill>
+                <a:latin typeface="Calibri"/>
+              </a:rPr>
+              <a:t>•  </a:t>
+            </a:r>
+            <a:r>
+              <a:rPr sz="1050" b="0" i="0">
+                <a:solidFill>
+                  <a:srgbClr val="1A1A1A"/>
+                </a:solidFill>
+                <a:latin typeface="Calibri"/>
+              </a:rPr>
+              <a:t>quasi-real photon: + 0.53 Q² (5 MeV at Q² = 0.01, 50 MeV at 0.1)</a:t>
             </a:r>
           </a:p>
         </p:txBody>
@@ -3699,8 +3757,8 @@
         </p:nvSpPr>
         <p:spPr>
           <a:xfrm>
-            <a:off x="7863840" y="2606040"/>
-            <a:ext cx="3886200" cy="2743200"/>
+            <a:off x="8001000" y="3291840"/>
+            <a:ext cx="3749039" cy="3017520"/>
           </a:xfrm>
           <a:prstGeom prst="roundRect">
             <a:avLst>
@@ -3745,8 +3803,8 @@
         </p:nvSpPr>
         <p:spPr>
           <a:xfrm>
-            <a:off x="8001000" y="2697480"/>
-            <a:ext cx="3611880" cy="2560320"/>
+            <a:off x="8138160" y="3383280"/>
+            <a:ext cx="3474720" cy="2834639"/>
           </a:xfrm>
           <a:prstGeom prst="rect">
             <a:avLst/>
@@ -3768,13 +3826,13 @@
               </a:spcAft>
             </a:pPr>
             <a:r>
-              <a:rPr sz="1300" b="1" i="0">
+              <a:rPr sz="1250" b="1" i="0">
                 <a:solidFill>
                   <a:srgbClr val="D55500"/>
                 </a:solidFill>
                 <a:latin typeface="Calibri"/>
               </a:rPr>
-              <a:t>Yes, for everything an analysis measures</a:t>
+              <a:t>The other prescriptions (rms vs true E_γ)</a:t>
             </a:r>
           </a:p>
           <a:p>
@@ -3787,7 +3845,7 @@
               </a:spcAft>
             </a:pPr>
             <a:r>
-              <a:rPr sz="1100" b="0" i="0">
+              <a:rPr sz="1050" b="0" i="0">
                 <a:solidFill>
                   <a:srgbClr val="1A1A1A"/>
                 </a:solidFill>
@@ -3796,13 +3854,13 @@
               <a:t>•  </a:t>
             </a:r>
             <a:r>
-              <a:rPr sz="1100" b="0" i="0">
-                <a:solidFill>
-                  <a:srgbClr val="1A1A1A"/>
-                </a:solidFill>
-                <a:latin typeface="Calibri"/>
-              </a:rPr>
-              <a:t>E_γ from the J/ψ alone (neutron at rest): smeared by 196 MeV rms above 8.6 GeV, shifted +120 MeV in 8.6–9.0 and +250 MeV next to threshold; 23–45 % of events move by more than 150 MeV</a:t>
+              <a:rPr sz="1050" b="0" i="0">
+                <a:solidFill>
+                  <a:srgbClr val="1A1A1A"/>
+                </a:solidFill>
+                <a:latin typeface="Calibri"/>
+              </a:rPr>
+              <a:t>E_ψ + E_n − M_n: −12 ± 24 MeV (spectator kinetic + binding energy)</a:t>
             </a:r>
           </a:p>
           <a:p>
@@ -3815,7 +3873,7 @@
               </a:spcAft>
             </a:pPr>
             <a:r>
-              <a:rPr sz="1100" b="0" i="0">
+              <a:rPr sz="1050" b="0" i="0">
                 <a:solidFill>
                   <a:srgbClr val="1A1A1A"/>
                 </a:solidFill>
@@ -3824,13 +3882,13 @@
               <a:t>•  </a:t>
             </a:r>
             <a:r>
-              <a:rPr sz="1100" b="0" i="0">
-                <a:solidFill>
-                  <a:srgbClr val="1A1A1A"/>
-                </a:solidFill>
-                <a:latin typeface="Calibri"/>
-              </a:rPr>
-              <a:t>t from the reconstructed photon: 0.24 GeV² rms, comparable to 1/b</a:t>
+              <a:rPr sz="1050" b="0" i="0">
+                <a:solidFill>
+                  <a:srgbClr val="1A1A1A"/>
+                </a:solidFill>
+                <a:latin typeface="Calibri"/>
+              </a:rPr>
+              <a:t>p_zψ + p_zn: −38 ± 85 MeV</a:t>
             </a:r>
           </a:p>
           <a:p>
@@ -3843,7 +3901,7 @@
               </a:spcAft>
             </a:pPr>
             <a:r>
-              <a:rPr sz="1100" b="0" i="0">
+              <a:rPr sz="1050" b="0" i="0">
                 <a:solidFill>
                   <a:srgbClr val="1A1A1A"/>
                 </a:solidFill>
@@ -3852,13 +3910,69 @@
               <a:t>•  </a:t>
             </a:r>
             <a:r>
-              <a:rPr sz="1100" b="0" i="0">
-                <a:solidFill>
-                  <a:srgbClr val="1A1A1A"/>
-                </a:solidFill>
-                <a:latin typeface="Calibri"/>
-              </a:rPr>
-              <a:t>threshold region (ratio 1.09 and 1.78), the 2.55 % below it, spectator protons, exclusivity-cut efficiencies: all Fermi motion</a:t>
+              <a:rPr sz="1050" b="0" i="0">
+                <a:solidFill>
+                  <a:srgbClr val="1A1A1A"/>
+                </a:solidFill>
+                <a:latin typeface="Calibri"/>
+              </a:rPr>
+              <a:t>J/ψ alone, neutron at rest: +40 ± 196 MeV, +250 next to threshold</a:t>
+            </a:r>
+          </a:p>
+          <a:p>
+            <a:pPr algn="l">
+              <a:lnSpc>
+                <a:spcPct val="105000"/>
+              </a:lnSpc>
+              <a:spcAft>
+                <a:spcPts val="300"/>
+              </a:spcAft>
+            </a:pPr>
+            <a:r>
+              <a:rPr sz="1050" b="0" i="0">
+                <a:solidFill>
+                  <a:srgbClr val="1A1A1A"/>
+                </a:solidFill>
+                <a:latin typeface="Calibri"/>
+              </a:rPr>
+              <a:t>•  </a:t>
+            </a:r>
+            <a:r>
+              <a:rPr sz="1050" b="0" i="0">
+                <a:solidFill>
+                  <a:srgbClr val="1A1A1A"/>
+                </a:solidFill>
+                <a:latin typeface="Calibri"/>
+              </a:rPr>
+              <a:t>(s − M_n²)/2M_n: +245 ± 667 MeV — not an estimator of E_γ, it is the free-neutron energy for the measured W</a:t>
+            </a:r>
+          </a:p>
+          <a:p>
+            <a:pPr algn="l">
+              <a:lnSpc>
+                <a:spcPct val="105000"/>
+              </a:lnSpc>
+              <a:spcAft>
+                <a:spcPts val="300"/>
+              </a:spcAft>
+            </a:pPr>
+            <a:r>
+              <a:rPr sz="1050" b="0" i="0">
+                <a:solidFill>
+                  <a:srgbClr val="1A1A1A"/>
+                </a:solidFill>
+                <a:latin typeface="Calibri"/>
+              </a:rPr>
+              <a:t>•  </a:t>
+            </a:r>
+            <a:r>
+              <a:rPr sz="1050" b="0" i="0">
+                <a:solidFill>
+                  <a:srgbClr val="1A1A1A"/>
+                </a:solidFill>
+                <a:latin typeface="Calibri"/>
+              </a:rPr>
+              <a:t>with resolution (J/ψ 1 %, neutron 10 %) Eq. 10 and the energy sum both give 135 MeV: the neutron momentum limits both</a:t>
             </a:r>
           </a:p>
         </p:txBody>
@@ -3871,8 +3985,8 @@
         </p:nvSpPr>
         <p:spPr>
           <a:xfrm>
-            <a:off x="457200" y="4343400"/>
-            <a:ext cx="7132320" cy="960120"/>
+            <a:off x="457200" y="6473952"/>
+            <a:ext cx="8229600" cy="274320"/>
           </a:xfrm>
           <a:prstGeom prst="rect">
             <a:avLst/>
@@ -3894,17 +4008,40 @@
               </a:spcAft>
             </a:pPr>
             <a:r>
-              <a:rPr sz="1400" b="1" i="0">
-                <a:solidFill>
-                  <a:srgbClr val="0072B2"/>
-                </a:solidFill>
-                <a:latin typeface="Calibri"/>
-              </a:rPr>
-              <a:t>Bottom line</a:t>
-            </a:r>
-          </a:p>
-          <a:p>
-            <a:pPr algn="l">
+              <a:rPr sz="900" b="0" i="0">
+                <a:solidFill>
+                  <a:srgbClr val="5F636B"/>
+                </a:solidFill>
+                <a:latin typeface="Calibri"/>
+              </a:rPr>
+              <a:t>V. Kubarovsky · Fermi motion in untagged J/ψ photoproduction · 27 September 2026</a:t>
+            </a:r>
+          </a:p>
+        </p:txBody>
+      </p:sp>
+      <p:sp>
+        <p:nvSpPr>
+          <p:cNvPr id="9" name="TextBox 8"/>
+          <p:cNvSpPr txBox="1"/>
+          <p:nvPr/>
+        </p:nvSpPr>
+        <p:spPr>
+          <a:xfrm>
+            <a:off x="11155680" y="6473952"/>
+            <a:ext cx="594360" cy="274320"/>
+          </a:xfrm>
+          <a:prstGeom prst="rect">
+            <a:avLst/>
+          </a:prstGeom>
+          <a:noFill/>
+        </p:spPr>
+        <p:txBody>
+          <a:bodyPr wrap="square" anchor="t" lIns="45720" rIns="45720" tIns="27432" bIns="27432">
+            <a:spAutoFit/>
+          </a:bodyPr>
+          <a:lstStyle/>
+          <a:p>
+            <a:pPr algn="r">
               <a:lnSpc>
                 <a:spcPct val="105000"/>
               </a:lnSpc>
@@ -3913,27 +4050,143 @@
               </a:spcAft>
             </a:pPr>
             <a:r>
-              <a:rPr sz="1200" b="0" i="0">
-                <a:solidFill>
-                  <a:srgbClr val="1A1A1A"/>
-                </a:solidFill>
-                <a:latin typeface="Calibri"/>
-              </a:rPr>
-              <a:t>Generate deuterium with Fermi motion always: it costs 0.65 ms per event and passes every acceptance test. The free-neutron sample keeps one role, the cross-check that isolates the effect. In the E_γ bins of the CLAS12 analysis (150–450 MeV wide) the migration from Fermi motion is larger than the detector resolution.</a:t>
-            </a:r>
-          </a:p>
-        </p:txBody>
-      </p:sp>
-      <p:sp>
-        <p:nvSpPr>
-          <p:cNvPr id="9" name="Rounded Rectangle 8"/>
+              <a:rPr sz="900" b="0" i="0">
+                <a:solidFill>
+                  <a:srgbClr val="5F636B"/>
+                </a:solidFill>
+                <a:latin typeface="Calibri"/>
+              </a:rPr>
+              <a:t>10</a:t>
+            </a:r>
+          </a:p>
+        </p:txBody>
+      </p:sp>
+    </p:spTree>
+  </p:cSld>
+  <p:clrMapOvr>
+    <a:masterClrMapping/>
+  </p:clrMapOvr>
+</p:sld>
+</file>
+
+<file path=ppt/slides/slide11.xml><?xml version="1.0" encoding="utf-8"?>
+<p:sld xmlns:a="http://schemas.openxmlformats.org/drawingml/2006/main" xmlns:p="http://schemas.openxmlformats.org/presentationml/2006/main" xmlns:r="http://schemas.openxmlformats.org/officeDocument/2006/relationships">
+  <p:cSld>
+    <p:bg>
+      <p:bgPr>
+        <a:solidFill>
+          <a:srgbClr val="FFFFFF"/>
+        </a:solidFill>
+        <a:effectLst/>
+      </p:bgPr>
+    </p:bg>
+    <p:spTree>
+      <p:nvGrpSpPr>
+        <p:cNvPr id="1" name=""/>
+        <p:cNvGrpSpPr/>
+        <p:nvPr/>
+      </p:nvGrpSpPr>
+      <p:grpSpPr/>
+      <p:sp>
+        <p:nvSpPr>
+          <p:cNvPr id="2" name="TextBox 1"/>
+          <p:cNvSpPr txBox="1"/>
+          <p:nvPr/>
+        </p:nvSpPr>
+        <p:spPr>
+          <a:xfrm>
+            <a:off x="457200" y="320040"/>
+            <a:ext cx="11247120" cy="685800"/>
+          </a:xfrm>
+          <a:prstGeom prst="rect">
+            <a:avLst/>
+          </a:prstGeom>
+          <a:noFill/>
+        </p:spPr>
+        <p:txBody>
+          <a:bodyPr wrap="square" anchor="ctr" lIns="45720" rIns="45720" tIns="27432" bIns="27432">
+            <a:spAutoFit/>
+          </a:bodyPr>
+          <a:lstStyle/>
+          <a:p>
+            <a:pPr algn="l">
+              <a:lnSpc>
+                <a:spcPct val="105000"/>
+              </a:lnSpc>
+              <a:spcAft>
+                <a:spcPts val="400"/>
+              </a:spcAft>
+            </a:pPr>
+            <a:r>
+              <a:rPr sz="2600" b="1" i="0">
+                <a:solidFill>
+                  <a:srgbClr val="1A1A1A"/>
+                </a:solidFill>
+                <a:latin typeface="Cambria"/>
+              </a:rPr>
+              <a:t>W rules the cross section; E_γ is a label on the deuteron</a:t>
+            </a:r>
+          </a:p>
+        </p:txBody>
+      </p:sp>
+      <p:pic>
+        <p:nvPicPr>
+          <p:cNvPr id="3" name="Picture 2" descr="jpsi_Eeff_vs_Egamma.png"/>
+          <p:cNvPicPr>
+            <a:picLocks noChangeAspect="1"/>
+          </p:cNvPicPr>
+          <p:nvPr/>
+        </p:nvPicPr>
+        <p:blipFill>
+          <a:blip r:embed="rId2"/>
+          <a:stretch>
+            <a:fillRect/>
+          </a:stretch>
+        </p:blipFill>
+        <p:spPr>
+          <a:xfrm>
+            <a:off x="365760" y="1005840"/>
+            <a:ext cx="7152050" cy="3246120"/>
+          </a:xfrm>
+          <a:prstGeom prst="rect">
+            <a:avLst/>
+          </a:prstGeom>
+        </p:spPr>
+      </p:pic>
+      <p:pic>
+        <p:nvPicPr>
+          <p:cNvPr id="4" name="Picture 3" descr="jpsi_effective_flux_W.png"/>
+          <p:cNvPicPr>
+            <a:picLocks noChangeAspect="1"/>
+          </p:cNvPicPr>
+          <p:nvPr/>
+        </p:nvPicPr>
+        <p:blipFill>
+          <a:blip r:embed="rId3"/>
+          <a:stretch>
+            <a:fillRect/>
+          </a:stretch>
+        </p:blipFill>
+        <p:spPr>
+          <a:xfrm>
+            <a:off x="365760" y="4343400"/>
+            <a:ext cx="4740963" cy="2011680"/>
+          </a:xfrm>
+          <a:prstGeom prst="rect">
+            <a:avLst/>
+          </a:prstGeom>
+        </p:spPr>
+      </p:pic>
+      <p:sp>
+        <p:nvSpPr>
+          <p:cNvPr id="5" name="Rounded Rectangle 4"/>
           <p:cNvSpPr/>
           <p:nvPr/>
         </p:nvSpPr>
         <p:spPr>
           <a:xfrm>
-            <a:off x="457200" y="5394960"/>
-            <a:ext cx="11292840" cy="960120"/>
+            <a:off x="8001000" y="1005840"/>
+            <a:ext cx="3749039" cy="2651760"/>
           </a:xfrm>
           <a:prstGeom prst="roundRect">
             <a:avLst>
@@ -3972,14 +4225,14 @@
       </p:sp>
       <p:sp>
         <p:nvSpPr>
-          <p:cNvPr id="10" name="TextBox 9"/>
+          <p:cNvPr id="6" name="TextBox 5"/>
           <p:cNvSpPr txBox="1"/>
           <p:nvPr/>
         </p:nvSpPr>
         <p:spPr>
           <a:xfrm>
-            <a:off x="594360" y="5486400"/>
-            <a:ext cx="11018519" cy="777240"/>
+            <a:off x="8138160" y="1097280"/>
+            <a:ext cx="3474720" cy="2468879"/>
           </a:xfrm>
           <a:prstGeom prst="rect">
             <a:avLst/>
@@ -4001,13 +4254,13 @@
               </a:spcAft>
             </a:pPr>
             <a:r>
-              <a:rPr sz="1300" b="1" i="0">
+              <a:rPr sz="1250" b="1" i="0">
                 <a:solidFill>
                   <a:srgbClr val="0072B2"/>
                 </a:solidFill>
                 <a:latin typeface="Calibri"/>
               </a:rPr>
-              <a:t>Next steps</a:t>
+              <a:t>What the plots show</a:t>
             </a:r>
           </a:p>
           <a:p>
@@ -4020,7 +4273,7 @@
               </a:spcAft>
             </a:pPr>
             <a:r>
-              <a:rPr sz="1100" b="0" i="0">
+              <a:rPr sz="1050" b="0" i="0">
                 <a:solidFill>
                   <a:srgbClr val="1A1A1A"/>
                 </a:solidFill>
@@ -4029,27 +4282,129 @@
               <a:t>•  </a:t>
             </a:r>
             <a:r>
-              <a:rPr sz="1100" b="0" i="0">
-                <a:solidFill>
-                  <a:srgbClr val="1A1A1A"/>
-                </a:solidFill>
-                <a:latin typeface="Calibri"/>
-              </a:rPr>
-              <a:t>J/ψ → e⁺e⁻γ decay radiation in the generator (15–20 % of decays below 3.0 GeV)  ·  flux factor (1 − β_z) in the electroproduction Fermi path  ·  refit A, α, B, b to the CLAS12 tables  ·  quasi-real electroproduction twin with RC for absolute CLAS12 yields</a:t>
-            </a:r>
-          </a:p>
-        </p:txBody>
-      </p:sp>
-      <p:sp>
-        <p:nvSpPr>
-          <p:cNvPr id="11" name="TextBox 10"/>
+              <a:rPr sz="1050" b="0" i="0">
+                <a:solidFill>
+                  <a:srgbClr val="1A1A1A"/>
+                </a:solidFill>
+                <a:latin typeface="Calibri"/>
+              </a:rPr>
+              <a:t>one lab E_γ feeds a band of W: 0.13 GeV rms (0.6–0.7 GeV in photon-energy units); mean 40–50 MeV above the free line</a:t>
+            </a:r>
+          </a:p>
+          <a:p>
+            <a:pPr algn="l">
+              <a:lnSpc>
+                <a:spcPct val="105000"/>
+              </a:lnSpc>
+              <a:spcAft>
+                <a:spcPts val="300"/>
+              </a:spcAft>
+            </a:pPr>
+            <a:r>
+              <a:rPr sz="1050" b="0" i="0">
+                <a:solidFill>
+                  <a:srgbClr val="1A1A1A"/>
+                </a:solidFill>
+                <a:latin typeface="Calibri"/>
+              </a:rPr>
+              <a:t>•  </a:t>
+            </a:r>
+            <a:r>
+              <a:rPr sz="1050" b="0" i="0">
+                <a:solidFill>
+                  <a:srgbClr val="1A1A1A"/>
+                </a:solidFill>
+                <a:latin typeface="Calibri"/>
+              </a:rPr>
+              <a:t>photons of 6.7–8.2 GeV produce the reaction at W = 4.17–4.22 GeV, the W of a 9 GeV photon on a free neutron: only the photon is sub-threshold</a:t>
+            </a:r>
+          </a:p>
+          <a:p>
+            <a:pPr algn="l">
+              <a:lnSpc>
+                <a:spcPct val="105000"/>
+              </a:lnSpc>
+              <a:spcAft>
+                <a:spcPts val="300"/>
+              </a:spcAft>
+            </a:pPr>
+            <a:r>
+              <a:rPr sz="1050" b="0" i="0">
+                <a:solidFill>
+                  <a:srgbClr val="1A1A1A"/>
+                </a:solidFill>
+                <a:latin typeface="Calibri"/>
+              </a:rPr>
+              <a:t>•  </a:t>
+            </a:r>
+            <a:r>
+              <a:rPr sz="1050" b="0" i="0">
+                <a:solidFill>
+                  <a:srgbClr val="1A1A1A"/>
+                </a:solidFill>
+                <a:latin typeface="Calibri"/>
+              </a:rPr>
+              <a:t>19 % of the events lie beyond the free-nucleon endpoint E₀</a:t>
+            </a:r>
+          </a:p>
+        </p:txBody>
+      </p:sp>
+      <p:sp>
+        <p:nvSpPr>
+          <p:cNvPr id="7" name="Rounded Rectangle 6"/>
+          <p:cNvSpPr/>
+          <p:nvPr/>
+        </p:nvSpPr>
+        <p:spPr>
+          <a:xfrm>
+            <a:off x="8001000" y="3794760"/>
+            <a:ext cx="3749039" cy="2560320"/>
+          </a:xfrm>
+          <a:prstGeom prst="roundRect">
+            <a:avLst>
+              <a:gd name="adj" fmla="val 6000"/>
+            </a:avLst>
+          </a:prstGeom>
+          <a:solidFill>
+            <a:srgbClr val="EEF2F7"/>
+          </a:solidFill>
+          <a:ln>
+            <a:noFill/>
+          </a:ln>
+          <a:effectLst/>
+        </p:spPr>
+        <p:style>
+          <a:lnRef idx="1">
+            <a:schemeClr val="accent1"/>
+          </a:lnRef>
+          <a:fillRef idx="3">
+            <a:schemeClr val="accent1"/>
+          </a:fillRef>
+          <a:effectRef idx="2">
+            <a:schemeClr val="accent1"/>
+          </a:effectRef>
+          <a:fontRef idx="minor">
+            <a:schemeClr val="lt1"/>
+          </a:fontRef>
+        </p:style>
+        <p:txBody>
+          <a:bodyPr rtlCol="0" anchor="ctr"/>
+          <a:lstStyle/>
+          <a:p>
+            <a:pPr algn="ctr"/>
+          </a:p>
+        </p:txBody>
+      </p:sp>
+      <p:sp>
+        <p:nvSpPr>
+          <p:cNvPr id="8" name="TextBox 7"/>
           <p:cNvSpPr txBox="1"/>
           <p:nvPr/>
         </p:nvSpPr>
         <p:spPr>
           <a:xfrm>
-            <a:off x="457200" y="6473952"/>
-            <a:ext cx="8229600" cy="274320"/>
+            <a:off x="8138160" y="3886200"/>
+            <a:ext cx="3474720" cy="2377439"/>
           </a:xfrm>
           <a:prstGeom prst="rect">
             <a:avLst/>
@@ -4067,31 +4422,143 @@
                 <a:spcPct val="105000"/>
               </a:lnSpc>
               <a:spcAft>
-                <a:spcPts val="400"/>
-              </a:spcAft>
-            </a:pPr>
-            <a:r>
-              <a:rPr sz="900" b="0" i="0">
-                <a:solidFill>
-                  <a:srgbClr val="5F636B"/>
-                </a:solidFill>
-                <a:latin typeface="Calibri"/>
-              </a:rPr>
-              <a:t>V. Kubarovsky · Fermi motion in untagged J/ψ photoproduction · 27 September 2026</a:t>
-            </a:r>
-          </a:p>
-        </p:txBody>
-      </p:sp>
-      <p:sp>
-        <p:nvSpPr>
-          <p:cNvPr id="12" name="TextBox 11"/>
+                <a:spcPts val="300"/>
+              </a:spcAft>
+            </a:pPr>
+            <a:r>
+              <a:rPr sz="1250" b="1" i="0">
+                <a:solidFill>
+                  <a:srgbClr val="009E73"/>
+                </a:solidFill>
+                <a:latin typeface="Calibri"/>
+              </a:rPr>
+              <a:t>Recipe</a:t>
+            </a:r>
+          </a:p>
+          <a:p>
+            <a:pPr algn="l">
+              <a:lnSpc>
+                <a:spcPct val="105000"/>
+              </a:lnSpc>
+              <a:spcAft>
+                <a:spcPts val="300"/>
+              </a:spcAft>
+            </a:pPr>
+            <a:r>
+              <a:rPr sz="1050" b="0" i="0">
+                <a:solidFill>
+                  <a:srgbClr val="1A1A1A"/>
+                </a:solidFill>
+                <a:latin typeface="Calibri"/>
+              </a:rPr>
+              <a:t>•  </a:t>
+            </a:r>
+            <a:r>
+              <a:rPr sz="1050" b="0" i="0">
+                <a:solidFill>
+                  <a:srgbClr val="1A1A1A"/>
+                </a:solidFill>
+                <a:latin typeface="Calibri"/>
+              </a:rPr>
+              <a:t>E_γ and p_s from Eq. 10; select |p_s| &lt; 0.15 GeV/c (84 %, m* within 26 MeV of M_n)</a:t>
+            </a:r>
+          </a:p>
+          <a:p>
+            <a:pPr algn="l">
+              <a:lnSpc>
+                <a:spcPct val="105000"/>
+              </a:lnSpc>
+              <a:spcAft>
+                <a:spcPts val="300"/>
+              </a:spcAft>
+            </a:pPr>
+            <a:r>
+              <a:rPr sz="1050" b="0" i="0">
+                <a:solidFill>
+                  <a:srgbClr val="1A1A1A"/>
+                </a:solidFill>
+                <a:latin typeface="Calibri"/>
+              </a:rPr>
+              <a:t>•  </a:t>
+            </a:r>
+            <a:r>
+              <a:rPr sz="1050" b="0" i="0">
+                <a:solidFill>
+                  <a:srgbClr val="1A1A1A"/>
+                </a:solidFill>
+                <a:latin typeface="Calibri"/>
+              </a:rPr>
+              <a:t>bin in W from p_ψ + p_n; divide by the effective flux Φ_d(W) from the generator: 2–3 % below the free flux up to 9 GeV, 10–40 % at the endpoint</a:t>
+            </a:r>
+          </a:p>
+          <a:p>
+            <a:pPr algn="l">
+              <a:lnSpc>
+                <a:spcPct val="105000"/>
+              </a:lnSpc>
+              <a:spcAft>
+                <a:spcPts val="300"/>
+              </a:spcAft>
+            </a:pPr>
+            <a:r>
+              <a:rPr sz="1050" b="0" i="0">
+                <a:solidFill>
+                  <a:srgbClr val="1A1A1A"/>
+                </a:solidFill>
+                <a:latin typeface="Calibri"/>
+              </a:rPr>
+              <a:t>•  </a:t>
+            </a:r>
+            <a:r>
+              <a:rPr sz="1050" b="0" i="0">
+                <a:solidFill>
+                  <a:srgbClr val="1A1A1A"/>
+                </a:solidFill>
+                <a:latin typeface="Calibri"/>
+              </a:rPr>
+              <a:t>quote ⟨E_γ⟩ ± rms per W bin as a second column; show proton data at the same W</a:t>
+            </a:r>
+          </a:p>
+          <a:p>
+            <a:pPr algn="l">
+              <a:lnSpc>
+                <a:spcPct val="105000"/>
+              </a:lnSpc>
+              <a:spcAft>
+                <a:spcPts val="300"/>
+              </a:spcAft>
+            </a:pPr>
+            <a:r>
+              <a:rPr sz="1050" b="0" i="0">
+                <a:solidFill>
+                  <a:srgbClr val="1A1A1A"/>
+                </a:solidFill>
+                <a:latin typeface="Calibri"/>
+              </a:rPr>
+              <a:t>•  </a:t>
+            </a:r>
+            <a:r>
+              <a:rPr sz="1050" b="0" i="0">
+                <a:solidFill>
+                  <a:srgbClr val="1A1A1A"/>
+                </a:solidFill>
+                <a:latin typeface="Calibri"/>
+              </a:rPr>
+              <a:t>systematics: prescription spread (10⁻³), wave function in Φ_d, stability of σ against p_s (pole limit)</a:t>
+            </a:r>
+          </a:p>
+        </p:txBody>
+      </p:sp>
+      <p:sp>
+        <p:nvSpPr>
+          <p:cNvPr id="9" name="TextBox 8"/>
           <p:cNvSpPr txBox="1"/>
           <p:nvPr/>
         </p:nvSpPr>
         <p:spPr>
           <a:xfrm>
-            <a:off x="11155680" y="6473952"/>
-            <a:ext cx="594360" cy="274320"/>
+            <a:off x="457200" y="6473952"/>
+            <a:ext cx="8229600" cy="274320"/>
           </a:xfrm>
           <a:prstGeom prst="rect">
             <a:avLst/>
@@ -4104,6 +4571,48 @@
           </a:bodyPr>
           <a:lstStyle/>
           <a:p>
+            <a:pPr algn="l">
+              <a:lnSpc>
+                <a:spcPct val="105000"/>
+              </a:lnSpc>
+              <a:spcAft>
+                <a:spcPts val="400"/>
+              </a:spcAft>
+            </a:pPr>
+            <a:r>
+              <a:rPr sz="900" b="0" i="0">
+                <a:solidFill>
+                  <a:srgbClr val="5F636B"/>
+                </a:solidFill>
+                <a:latin typeface="Calibri"/>
+              </a:rPr>
+              <a:t>V. Kubarovsky · Fermi motion in untagged J/ψ photoproduction · 27 September 2026</a:t>
+            </a:r>
+          </a:p>
+        </p:txBody>
+      </p:sp>
+      <p:sp>
+        <p:nvSpPr>
+          <p:cNvPr id="10" name="TextBox 9"/>
+          <p:cNvSpPr txBox="1"/>
+          <p:nvPr/>
+        </p:nvSpPr>
+        <p:spPr>
+          <a:xfrm>
+            <a:off x="11155680" y="6473952"/>
+            <a:ext cx="594360" cy="274320"/>
+          </a:xfrm>
+          <a:prstGeom prst="rect">
+            <a:avLst/>
+          </a:prstGeom>
+          <a:noFill/>
+        </p:spPr>
+        <p:txBody>
+          <a:bodyPr wrap="square" anchor="t" lIns="45720" rIns="45720" tIns="27432" bIns="27432">
+            <a:spAutoFit/>
+          </a:bodyPr>
+          <a:lstStyle/>
+          <a:p>
             <a:pPr algn="r">
               <a:lnSpc>
                 <a:spcPct val="105000"/>
@@ -4119,7 +4628,648 @@
                 </a:solidFill>
                 <a:latin typeface="Calibri"/>
               </a:rPr>
-              <a:t>10</a:t>
+              <a:t>11</a:t>
+            </a:r>
+          </a:p>
+        </p:txBody>
+      </p:sp>
+    </p:spTree>
+  </p:cSld>
+  <p:clrMapOvr>
+    <a:masterClrMapping/>
+  </p:clrMapOvr>
+</p:sld>
+</file>
+
+<file path=ppt/slides/slide12.xml><?xml version="1.0" encoding="utf-8"?>
+<p:sld xmlns:a="http://schemas.openxmlformats.org/drawingml/2006/main" xmlns:p="http://schemas.openxmlformats.org/presentationml/2006/main" xmlns:r="http://schemas.openxmlformats.org/officeDocument/2006/relationships">
+  <p:cSld>
+    <p:bg>
+      <p:bgPr>
+        <a:solidFill>
+          <a:srgbClr val="FFFFFF"/>
+        </a:solidFill>
+        <a:effectLst/>
+      </p:bgPr>
+    </p:bg>
+    <p:spTree>
+      <p:nvGrpSpPr>
+        <p:cNvPr id="1" name=""/>
+        <p:cNvGrpSpPr/>
+        <p:nvPr/>
+      </p:nvGrpSpPr>
+      <p:grpSpPr/>
+      <p:sp>
+        <p:nvSpPr>
+          <p:cNvPr id="2" name="TextBox 1"/>
+          <p:cNvSpPr txBox="1"/>
+          <p:nvPr/>
+        </p:nvSpPr>
+        <p:spPr>
+          <a:xfrm>
+            <a:off x="457200" y="320040"/>
+            <a:ext cx="11247120" cy="685800"/>
+          </a:xfrm>
+          <a:prstGeom prst="rect">
+            <a:avLst/>
+          </a:prstGeom>
+          <a:noFill/>
+        </p:spPr>
+        <p:txBody>
+          <a:bodyPr wrap="square" anchor="ctr" lIns="45720" rIns="45720" tIns="27432" bIns="27432">
+            <a:spAutoFit/>
+          </a:bodyPr>
+          <a:lstStyle/>
+          <a:p>
+            <a:pPr algn="l">
+              <a:lnSpc>
+                <a:spcPct val="105000"/>
+              </a:lnSpc>
+              <a:spcAft>
+                <a:spcPts val="400"/>
+              </a:spcAft>
+            </a:pPr>
+            <a:r>
+              <a:rPr sz="2600" b="1" i="0">
+                <a:solidFill>
+                  <a:srgbClr val="1A1A1A"/>
+                </a:solidFill>
+                <a:latin typeface="Cambria"/>
+              </a:rPr>
+              <a:t>Conclusion: do we need a Monte Carlo with Fermi motion?</a:t>
+            </a:r>
+          </a:p>
+        </p:txBody>
+      </p:sp>
+      <p:pic>
+        <p:nvPicPr>
+          <p:cNvPr id="3" name="Picture 2" descr="fig_ereco.png"/>
+          <p:cNvPicPr>
+            <a:picLocks noChangeAspect="1"/>
+          </p:cNvPicPr>
+          <p:nvPr/>
+        </p:nvPicPr>
+        <p:blipFill>
+          <a:blip r:embed="rId2"/>
+          <a:stretch>
+            <a:fillRect/>
+          </a:stretch>
+        </p:blipFill>
+        <p:spPr>
+          <a:xfrm>
+            <a:off x="365760" y="1051560"/>
+            <a:ext cx="7223760" cy="3054982"/>
+          </a:xfrm>
+          <a:prstGeom prst="rect">
+            <a:avLst/>
+          </a:prstGeom>
+        </p:spPr>
+      </p:pic>
+      <p:sp>
+        <p:nvSpPr>
+          <p:cNvPr id="4" name="Rounded Rectangle 3"/>
+          <p:cNvSpPr/>
+          <p:nvPr/>
+        </p:nvSpPr>
+        <p:spPr>
+          <a:xfrm>
+            <a:off x="7863840" y="1051560"/>
+            <a:ext cx="3886200" cy="1417320"/>
+          </a:xfrm>
+          <a:prstGeom prst="roundRect">
+            <a:avLst>
+              <a:gd name="adj" fmla="val 6000"/>
+            </a:avLst>
+          </a:prstGeom>
+          <a:solidFill>
+            <a:srgbClr val="EEF2F7"/>
+          </a:solidFill>
+          <a:ln>
+            <a:noFill/>
+          </a:ln>
+          <a:effectLst/>
+        </p:spPr>
+        <p:style>
+          <a:lnRef idx="1">
+            <a:schemeClr val="accent1"/>
+          </a:lnRef>
+          <a:fillRef idx="3">
+            <a:schemeClr val="accent1"/>
+          </a:fillRef>
+          <a:effectRef idx="2">
+            <a:schemeClr val="accent1"/>
+          </a:effectRef>
+          <a:fontRef idx="minor">
+            <a:schemeClr val="lt1"/>
+          </a:fontRef>
+        </p:style>
+        <p:txBody>
+          <a:bodyPr rtlCol="0" anchor="ctr"/>
+          <a:lstStyle/>
+          <a:p>
+            <a:pPr algn="ctr"/>
+          </a:p>
+        </p:txBody>
+      </p:sp>
+      <p:sp>
+        <p:nvSpPr>
+          <p:cNvPr id="5" name="TextBox 4"/>
+          <p:cNvSpPr txBox="1"/>
+          <p:nvPr/>
+        </p:nvSpPr>
+        <p:spPr>
+          <a:xfrm>
+            <a:off x="8001000" y="1143000"/>
+            <a:ext cx="3611880" cy="1234440"/>
+          </a:xfrm>
+          <a:prstGeom prst="rect">
+            <a:avLst/>
+          </a:prstGeom>
+          <a:noFill/>
+        </p:spPr>
+        <p:txBody>
+          <a:bodyPr wrap="square" anchor="t" lIns="45720" rIns="45720" tIns="27432" bIns="27432">
+            <a:spAutoFit/>
+          </a:bodyPr>
+          <a:lstStyle/>
+          <a:p>
+            <a:pPr algn="l">
+              <a:lnSpc>
+                <a:spcPct val="105000"/>
+              </a:lnSpc>
+              <a:spcAft>
+                <a:spcPts val="300"/>
+              </a:spcAft>
+            </a:pPr>
+            <a:r>
+              <a:rPr sz="1300" b="1" i="0">
+                <a:solidFill>
+                  <a:srgbClr val="009E73"/>
+                </a:solidFill>
+                <a:latin typeface="Calibri"/>
+              </a:rPr>
+              <a:t>No, for the yield at the true E_γ</a:t>
+            </a:r>
+          </a:p>
+          <a:p>
+            <a:pPr algn="l">
+              <a:lnSpc>
+                <a:spcPct val="105000"/>
+              </a:lnSpc>
+              <a:spcAft>
+                <a:spcPts val="300"/>
+              </a:spcAft>
+            </a:pPr>
+            <a:r>
+              <a:rPr sz="1100" b="0" i="0">
+                <a:solidFill>
+                  <a:srgbClr val="1A1A1A"/>
+                </a:solidFill>
+                <a:latin typeface="Calibri"/>
+              </a:rPr>
+              <a:t>•  </a:t>
+            </a:r>
+            <a:r>
+              <a:rPr sz="1100" b="0" i="0">
+                <a:solidFill>
+                  <a:srgbClr val="1A1A1A"/>
+                </a:solidFill>
+                <a:latin typeface="Calibri"/>
+              </a:rPr>
+              <a:t>above 8.6 GeV a free-neutron generator gives the yield per neutron to better than 1 % in every bin, and the same t distribution at the true s</a:t>
+            </a:r>
+          </a:p>
+        </p:txBody>
+      </p:sp>
+      <p:sp>
+        <p:nvSpPr>
+          <p:cNvPr id="6" name="Rounded Rectangle 5"/>
+          <p:cNvSpPr/>
+          <p:nvPr/>
+        </p:nvSpPr>
+        <p:spPr>
+          <a:xfrm>
+            <a:off x="7863840" y="2606040"/>
+            <a:ext cx="3886200" cy="2743200"/>
+          </a:xfrm>
+          <a:prstGeom prst="roundRect">
+            <a:avLst>
+              <a:gd name="adj" fmla="val 6000"/>
+            </a:avLst>
+          </a:prstGeom>
+          <a:solidFill>
+            <a:srgbClr val="EEF2F7"/>
+          </a:solidFill>
+          <a:ln>
+            <a:noFill/>
+          </a:ln>
+          <a:effectLst/>
+        </p:spPr>
+        <p:style>
+          <a:lnRef idx="1">
+            <a:schemeClr val="accent1"/>
+          </a:lnRef>
+          <a:fillRef idx="3">
+            <a:schemeClr val="accent1"/>
+          </a:fillRef>
+          <a:effectRef idx="2">
+            <a:schemeClr val="accent1"/>
+          </a:effectRef>
+          <a:fontRef idx="minor">
+            <a:schemeClr val="lt1"/>
+          </a:fontRef>
+        </p:style>
+        <p:txBody>
+          <a:bodyPr rtlCol="0" anchor="ctr"/>
+          <a:lstStyle/>
+          <a:p>
+            <a:pPr algn="ctr"/>
+          </a:p>
+        </p:txBody>
+      </p:sp>
+      <p:sp>
+        <p:nvSpPr>
+          <p:cNvPr id="7" name="TextBox 6"/>
+          <p:cNvSpPr txBox="1"/>
+          <p:nvPr/>
+        </p:nvSpPr>
+        <p:spPr>
+          <a:xfrm>
+            <a:off x="8001000" y="2697480"/>
+            <a:ext cx="3611880" cy="2560320"/>
+          </a:xfrm>
+          <a:prstGeom prst="rect">
+            <a:avLst/>
+          </a:prstGeom>
+          <a:noFill/>
+        </p:spPr>
+        <p:txBody>
+          <a:bodyPr wrap="square" anchor="t" lIns="45720" rIns="45720" tIns="27432" bIns="27432">
+            <a:spAutoFit/>
+          </a:bodyPr>
+          <a:lstStyle/>
+          <a:p>
+            <a:pPr algn="l">
+              <a:lnSpc>
+                <a:spcPct val="105000"/>
+              </a:lnSpc>
+              <a:spcAft>
+                <a:spcPts val="300"/>
+              </a:spcAft>
+            </a:pPr>
+            <a:r>
+              <a:rPr sz="1300" b="1" i="0">
+                <a:solidFill>
+                  <a:srgbClr val="D55500"/>
+                </a:solidFill>
+                <a:latin typeface="Calibri"/>
+              </a:rPr>
+              <a:t>Yes, for everything an analysis measures</a:t>
+            </a:r>
+          </a:p>
+          <a:p>
+            <a:pPr algn="l">
+              <a:lnSpc>
+                <a:spcPct val="105000"/>
+              </a:lnSpc>
+              <a:spcAft>
+                <a:spcPts val="300"/>
+              </a:spcAft>
+            </a:pPr>
+            <a:r>
+              <a:rPr sz="1100" b="0" i="0">
+                <a:solidFill>
+                  <a:srgbClr val="1A1A1A"/>
+                </a:solidFill>
+                <a:latin typeface="Calibri"/>
+              </a:rPr>
+              <a:t>•  </a:t>
+            </a:r>
+            <a:r>
+              <a:rPr sz="1100" b="0" i="0">
+                <a:solidFill>
+                  <a:srgbClr val="1A1A1A"/>
+                </a:solidFill>
+                <a:latin typeface="Calibri"/>
+              </a:rPr>
+              <a:t>E_γ from the J/ψ alone (neutron at rest): smeared by 196 MeV rms above 8.6 GeV, shifted +120 MeV in 8.6–9.0 and +250 MeV next to threshold; 23–45 % of events move by more than 150 MeV</a:t>
+            </a:r>
+          </a:p>
+          <a:p>
+            <a:pPr algn="l">
+              <a:lnSpc>
+                <a:spcPct val="105000"/>
+              </a:lnSpc>
+              <a:spcAft>
+                <a:spcPts val="300"/>
+              </a:spcAft>
+            </a:pPr>
+            <a:r>
+              <a:rPr sz="1100" b="0" i="0">
+                <a:solidFill>
+                  <a:srgbClr val="1A1A1A"/>
+                </a:solidFill>
+                <a:latin typeface="Calibri"/>
+              </a:rPr>
+              <a:t>•  </a:t>
+            </a:r>
+            <a:r>
+              <a:rPr sz="1100" b="0" i="0">
+                <a:solidFill>
+                  <a:srgbClr val="1A1A1A"/>
+                </a:solidFill>
+                <a:latin typeface="Calibri"/>
+              </a:rPr>
+              <a:t>t from the reconstructed photon: 0.24 GeV² rms, comparable to 1/b</a:t>
+            </a:r>
+          </a:p>
+          <a:p>
+            <a:pPr algn="l">
+              <a:lnSpc>
+                <a:spcPct val="105000"/>
+              </a:lnSpc>
+              <a:spcAft>
+                <a:spcPts val="300"/>
+              </a:spcAft>
+            </a:pPr>
+            <a:r>
+              <a:rPr sz="1100" b="0" i="0">
+                <a:solidFill>
+                  <a:srgbClr val="1A1A1A"/>
+                </a:solidFill>
+                <a:latin typeface="Calibri"/>
+              </a:rPr>
+              <a:t>•  </a:t>
+            </a:r>
+            <a:r>
+              <a:rPr sz="1100" b="0" i="0">
+                <a:solidFill>
+                  <a:srgbClr val="1A1A1A"/>
+                </a:solidFill>
+                <a:latin typeface="Calibri"/>
+              </a:rPr>
+              <a:t>threshold region (ratio 1.09 and 1.78), the 2.55 % below it, spectator protons, exclusivity-cut efficiencies: all Fermi motion</a:t>
+            </a:r>
+          </a:p>
+        </p:txBody>
+      </p:sp>
+      <p:sp>
+        <p:nvSpPr>
+          <p:cNvPr id="8" name="TextBox 7"/>
+          <p:cNvSpPr txBox="1"/>
+          <p:nvPr/>
+        </p:nvSpPr>
+        <p:spPr>
+          <a:xfrm>
+            <a:off x="457200" y="4343400"/>
+            <a:ext cx="7132320" cy="960120"/>
+          </a:xfrm>
+          <a:prstGeom prst="rect">
+            <a:avLst/>
+          </a:prstGeom>
+          <a:noFill/>
+        </p:spPr>
+        <p:txBody>
+          <a:bodyPr wrap="square" anchor="t" lIns="45720" rIns="45720" tIns="27432" bIns="27432">
+            <a:spAutoFit/>
+          </a:bodyPr>
+          <a:lstStyle/>
+          <a:p>
+            <a:pPr algn="l">
+              <a:lnSpc>
+                <a:spcPct val="105000"/>
+              </a:lnSpc>
+              <a:spcAft>
+                <a:spcPts val="400"/>
+              </a:spcAft>
+            </a:pPr>
+            <a:r>
+              <a:rPr sz="1400" b="1" i="0">
+                <a:solidFill>
+                  <a:srgbClr val="0072B2"/>
+                </a:solidFill>
+                <a:latin typeface="Calibri"/>
+              </a:rPr>
+              <a:t>Bottom line</a:t>
+            </a:r>
+          </a:p>
+          <a:p>
+            <a:pPr algn="l">
+              <a:lnSpc>
+                <a:spcPct val="105000"/>
+              </a:lnSpc>
+              <a:spcAft>
+                <a:spcPts val="400"/>
+              </a:spcAft>
+            </a:pPr>
+            <a:r>
+              <a:rPr sz="1200" b="0" i="0">
+                <a:solidFill>
+                  <a:srgbClr val="1A1A1A"/>
+                </a:solidFill>
+                <a:latin typeface="Calibri"/>
+              </a:rPr>
+              <a:t>Generate deuterium with Fermi motion always: it costs 0.65 ms per event and passes every acceptance test. The free-neutron sample keeps one role, the cross-check that isolates the effect. In the E_γ bins of the CLAS12 analysis (150–450 MeV wide) the migration from Fermi motion is larger than the detector resolution.</a:t>
+            </a:r>
+          </a:p>
+        </p:txBody>
+      </p:sp>
+      <p:sp>
+        <p:nvSpPr>
+          <p:cNvPr id="9" name="Rounded Rectangle 8"/>
+          <p:cNvSpPr/>
+          <p:nvPr/>
+        </p:nvSpPr>
+        <p:spPr>
+          <a:xfrm>
+            <a:off x="457200" y="5394960"/>
+            <a:ext cx="11292840" cy="960120"/>
+          </a:xfrm>
+          <a:prstGeom prst="roundRect">
+            <a:avLst>
+              <a:gd name="adj" fmla="val 6000"/>
+            </a:avLst>
+          </a:prstGeom>
+          <a:solidFill>
+            <a:srgbClr val="EEF2F7"/>
+          </a:solidFill>
+          <a:ln>
+            <a:noFill/>
+          </a:ln>
+          <a:effectLst/>
+        </p:spPr>
+        <p:style>
+          <a:lnRef idx="1">
+            <a:schemeClr val="accent1"/>
+          </a:lnRef>
+          <a:fillRef idx="3">
+            <a:schemeClr val="accent1"/>
+          </a:fillRef>
+          <a:effectRef idx="2">
+            <a:schemeClr val="accent1"/>
+          </a:effectRef>
+          <a:fontRef idx="minor">
+            <a:schemeClr val="lt1"/>
+          </a:fontRef>
+        </p:style>
+        <p:txBody>
+          <a:bodyPr rtlCol="0" anchor="ctr"/>
+          <a:lstStyle/>
+          <a:p>
+            <a:pPr algn="ctr"/>
+          </a:p>
+        </p:txBody>
+      </p:sp>
+      <p:sp>
+        <p:nvSpPr>
+          <p:cNvPr id="10" name="TextBox 9"/>
+          <p:cNvSpPr txBox="1"/>
+          <p:nvPr/>
+        </p:nvSpPr>
+        <p:spPr>
+          <a:xfrm>
+            <a:off x="594360" y="5486400"/>
+            <a:ext cx="11018519" cy="777240"/>
+          </a:xfrm>
+          <a:prstGeom prst="rect">
+            <a:avLst/>
+          </a:prstGeom>
+          <a:noFill/>
+        </p:spPr>
+        <p:txBody>
+          <a:bodyPr wrap="square" anchor="t" lIns="45720" rIns="45720" tIns="27432" bIns="27432">
+            <a:spAutoFit/>
+          </a:bodyPr>
+          <a:lstStyle/>
+          <a:p>
+            <a:pPr algn="l">
+              <a:lnSpc>
+                <a:spcPct val="105000"/>
+              </a:lnSpc>
+              <a:spcAft>
+                <a:spcPts val="300"/>
+              </a:spcAft>
+            </a:pPr>
+            <a:r>
+              <a:rPr sz="1300" b="1" i="0">
+                <a:solidFill>
+                  <a:srgbClr val="0072B2"/>
+                </a:solidFill>
+                <a:latin typeface="Calibri"/>
+              </a:rPr>
+              <a:t>Next steps</a:t>
+            </a:r>
+          </a:p>
+          <a:p>
+            <a:pPr algn="l">
+              <a:lnSpc>
+                <a:spcPct val="105000"/>
+              </a:lnSpc>
+              <a:spcAft>
+                <a:spcPts val="300"/>
+              </a:spcAft>
+            </a:pPr>
+            <a:r>
+              <a:rPr sz="1100" b="0" i="0">
+                <a:solidFill>
+                  <a:srgbClr val="1A1A1A"/>
+                </a:solidFill>
+                <a:latin typeface="Calibri"/>
+              </a:rPr>
+              <a:t>•  </a:t>
+            </a:r>
+            <a:r>
+              <a:rPr sz="1100" b="0" i="0">
+                <a:solidFill>
+                  <a:srgbClr val="1A1A1A"/>
+                </a:solidFill>
+                <a:latin typeface="Calibri"/>
+              </a:rPr>
+              <a:t>present σ(γn → J/ψ n) against W with Φ_d(W) from this generator  ·  J/ψ → e⁺e⁻γ decay radiation (15–20 % of decays below 3.0 GeV)  ·  flux factor (1 − β_z) in the electroproduction Fermi path  ·  refit A, α, B, b to the CLAS12 tables  ·  quasi-real electro twin with RC for absolute yields</a:t>
+            </a:r>
+          </a:p>
+        </p:txBody>
+      </p:sp>
+      <p:sp>
+        <p:nvSpPr>
+          <p:cNvPr id="11" name="TextBox 10"/>
+          <p:cNvSpPr txBox="1"/>
+          <p:nvPr/>
+        </p:nvSpPr>
+        <p:spPr>
+          <a:xfrm>
+            <a:off x="457200" y="6473952"/>
+            <a:ext cx="8229600" cy="274320"/>
+          </a:xfrm>
+          <a:prstGeom prst="rect">
+            <a:avLst/>
+          </a:prstGeom>
+          <a:noFill/>
+        </p:spPr>
+        <p:txBody>
+          <a:bodyPr wrap="square" anchor="t" lIns="45720" rIns="45720" tIns="27432" bIns="27432">
+            <a:spAutoFit/>
+          </a:bodyPr>
+          <a:lstStyle/>
+          <a:p>
+            <a:pPr algn="l">
+              <a:lnSpc>
+                <a:spcPct val="105000"/>
+              </a:lnSpc>
+              <a:spcAft>
+                <a:spcPts val="400"/>
+              </a:spcAft>
+            </a:pPr>
+            <a:r>
+              <a:rPr sz="900" b="0" i="0">
+                <a:solidFill>
+                  <a:srgbClr val="5F636B"/>
+                </a:solidFill>
+                <a:latin typeface="Calibri"/>
+              </a:rPr>
+              <a:t>V. Kubarovsky · Fermi motion in untagged J/ψ photoproduction · 27 September 2026</a:t>
+            </a:r>
+          </a:p>
+        </p:txBody>
+      </p:sp>
+      <p:sp>
+        <p:nvSpPr>
+          <p:cNvPr id="12" name="TextBox 11"/>
+          <p:cNvSpPr txBox="1"/>
+          <p:nvPr/>
+        </p:nvSpPr>
+        <p:spPr>
+          <a:xfrm>
+            <a:off x="11155680" y="6473952"/>
+            <a:ext cx="594360" cy="274320"/>
+          </a:xfrm>
+          <a:prstGeom prst="rect">
+            <a:avLst/>
+          </a:prstGeom>
+          <a:noFill/>
+        </p:spPr>
+        <p:txBody>
+          <a:bodyPr wrap="square" anchor="t" lIns="45720" rIns="45720" tIns="27432" bIns="27432">
+            <a:spAutoFit/>
+          </a:bodyPr>
+          <a:lstStyle/>
+          <a:p>
+            <a:pPr algn="r">
+              <a:lnSpc>
+                <a:spcPct val="105000"/>
+              </a:lnSpc>
+              <a:spcAft>
+                <a:spcPts val="400"/>
+              </a:spcAft>
+            </a:pPr>
+            <a:r>
+              <a:rPr sz="900" b="0" i="0">
+                <a:solidFill>
+                  <a:srgbClr val="5F636B"/>
+                </a:solidFill>
+                <a:latin typeface="Calibri"/>
+              </a:rPr>
+              <a:t>12</a:t>
             </a:r>
           </a:p>
         </p:txBody>

</xml_diff>